<commit_message>
First working version of the tripod-based calibration.
</commit_message>
<xml_diff>
--- a/doc/Calibrator.pptx
+++ b/doc/Calibrator.pptx
@@ -6,6 +6,7 @@
   </p:sldMasterIdLst>
   <p:sldIdLst>
     <p:sldId id="756" r:id="rId2"/>
+    <p:sldId id="757" r:id="rId3"/>
   </p:sldIdLst>
   <p:sldSz cx="12192000" cy="6858000"/>
   <p:notesSz cx="6858000" cy="9144000"/>
@@ -104,6 +105,11 @@
       </a:defRPr>
     </a:lvl9pPr>
   </p:defaultTextStyle>
+  <p:extLst>
+    <p:ext uri="{EFAFB233-063F-42B5-8137-9DF3F51BA10A}">
+      <p15:sldGuideLst xmlns:p15="http://schemas.microsoft.com/office/powerpoint/2012/main"/>
+    </p:ext>
+  </p:extLst>
 </p:presentation>
 </file>
 
@@ -254,7 +260,7 @@
           <a:p>
             <a:fld id="{0DCCD905-0181-4D8C-950E-363B15A3AAFF}" type="datetimeFigureOut">
               <a:rPr lang="en-US" smtClean="0"/>
-              <a:t>8/28/2022</a:t>
+              <a:t>10/31/2023</a:t>
             </a:fld>
             <a:endParaRPr lang="en-US"/>
           </a:p>
@@ -452,7 +458,7 @@
           <a:p>
             <a:fld id="{0DCCD905-0181-4D8C-950E-363B15A3AAFF}" type="datetimeFigureOut">
               <a:rPr lang="en-US" smtClean="0"/>
-              <a:t>8/28/2022</a:t>
+              <a:t>10/31/2023</a:t>
             </a:fld>
             <a:endParaRPr lang="en-US"/>
           </a:p>
@@ -660,7 +666,7 @@
           <a:p>
             <a:fld id="{0DCCD905-0181-4D8C-950E-363B15A3AAFF}" type="datetimeFigureOut">
               <a:rPr lang="en-US" smtClean="0"/>
-              <a:t>8/28/2022</a:t>
+              <a:t>10/31/2023</a:t>
             </a:fld>
             <a:endParaRPr lang="en-US"/>
           </a:p>
@@ -858,7 +864,7 @@
           <a:p>
             <a:fld id="{0DCCD905-0181-4D8C-950E-363B15A3AAFF}" type="datetimeFigureOut">
               <a:rPr lang="en-US" smtClean="0"/>
-              <a:t>8/28/2022</a:t>
+              <a:t>10/31/2023</a:t>
             </a:fld>
             <a:endParaRPr lang="en-US"/>
           </a:p>
@@ -1133,7 +1139,7 @@
           <a:p>
             <a:fld id="{0DCCD905-0181-4D8C-950E-363B15A3AAFF}" type="datetimeFigureOut">
               <a:rPr lang="en-US" smtClean="0"/>
-              <a:t>8/28/2022</a:t>
+              <a:t>10/31/2023</a:t>
             </a:fld>
             <a:endParaRPr lang="en-US"/>
           </a:p>
@@ -1398,7 +1404,7 @@
           <a:p>
             <a:fld id="{0DCCD905-0181-4D8C-950E-363B15A3AAFF}" type="datetimeFigureOut">
               <a:rPr lang="en-US" smtClean="0"/>
-              <a:t>8/28/2022</a:t>
+              <a:t>10/31/2023</a:t>
             </a:fld>
             <a:endParaRPr lang="en-US"/>
           </a:p>
@@ -1810,7 +1816,7 @@
           <a:p>
             <a:fld id="{0DCCD905-0181-4D8C-950E-363B15A3AAFF}" type="datetimeFigureOut">
               <a:rPr lang="en-US" smtClean="0"/>
-              <a:t>8/28/2022</a:t>
+              <a:t>10/31/2023</a:t>
             </a:fld>
             <a:endParaRPr lang="en-US"/>
           </a:p>
@@ -1951,7 +1957,7 @@
           <a:p>
             <a:fld id="{0DCCD905-0181-4D8C-950E-363B15A3AAFF}" type="datetimeFigureOut">
               <a:rPr lang="en-US" smtClean="0"/>
-              <a:t>8/28/2022</a:t>
+              <a:t>10/31/2023</a:t>
             </a:fld>
             <a:endParaRPr lang="en-US"/>
           </a:p>
@@ -2064,7 +2070,7 @@
           <a:p>
             <a:fld id="{0DCCD905-0181-4D8C-950E-363B15A3AAFF}" type="datetimeFigureOut">
               <a:rPr lang="en-US" smtClean="0"/>
-              <a:t>8/28/2022</a:t>
+              <a:t>10/31/2023</a:t>
             </a:fld>
             <a:endParaRPr lang="en-US"/>
           </a:p>
@@ -2375,7 +2381,7 @@
           <a:p>
             <a:fld id="{0DCCD905-0181-4D8C-950E-363B15A3AAFF}" type="datetimeFigureOut">
               <a:rPr lang="en-US" smtClean="0"/>
-              <a:t>8/28/2022</a:t>
+              <a:t>10/31/2023</a:t>
             </a:fld>
             <a:endParaRPr lang="en-US"/>
           </a:p>
@@ -2663,7 +2669,7 @@
           <a:p>
             <a:fld id="{0DCCD905-0181-4D8C-950E-363B15A3AAFF}" type="datetimeFigureOut">
               <a:rPr lang="en-US" smtClean="0"/>
-              <a:t>8/28/2022</a:t>
+              <a:t>10/31/2023</a:t>
             </a:fld>
             <a:endParaRPr lang="en-US"/>
           </a:p>
@@ -2904,7 +2910,7 @@
           <a:p>
             <a:fld id="{0DCCD905-0181-4D8C-950E-363B15A3AAFF}" type="datetimeFigureOut">
               <a:rPr lang="en-US" smtClean="0"/>
-              <a:t>8/28/2022</a:t>
+              <a:t>10/31/2023</a:t>
             </a:fld>
             <a:endParaRPr lang="en-US"/>
           </a:p>
@@ -6109,9 +6115,9 @@
               <a:avLst/>
             </a:prstGeom>
             <a:noFill/>
-            <a:ln w="12700">
+            <a:ln w="38100">
               <a:solidFill>
-                <a:schemeClr val="tx1"/>
+                <a:srgbClr val="FF0000"/>
               </a:solidFill>
               <a:prstDash val="solid"/>
             </a:ln>
@@ -6139,7 +6145,7 @@
               <a:r>
                 <a:rPr lang="en-US" sz="1000" dirty="0">
                   <a:solidFill>
-                    <a:schemeClr val="tx1"/>
+                    <a:srgbClr val="FF0000"/>
                   </a:solidFill>
                   <a:latin typeface="Courier New" panose="02070309020205020404" pitchFamily="49" charset="0"/>
                   <a:cs typeface="Courier New" panose="02070309020205020404" pitchFamily="49" charset="0"/>
@@ -6149,7 +6155,7 @@
               <a:r>
                 <a:rPr lang="en-US" sz="1000" dirty="0" err="1">
                   <a:solidFill>
-                    <a:schemeClr val="tx1"/>
+                    <a:srgbClr val="FF0000"/>
                   </a:solidFill>
                   <a:latin typeface="Courier New" panose="02070309020205020404" pitchFamily="49" charset="0"/>
                   <a:cs typeface="Courier New" panose="02070309020205020404" pitchFamily="49" charset="0"/>
@@ -6159,7 +6165,7 @@
               <a:r>
                 <a:rPr lang="en-US" sz="1000" dirty="0">
                   <a:solidFill>
-                    <a:schemeClr val="tx1"/>
+                    <a:srgbClr val="FF0000"/>
                   </a:solidFill>
                   <a:latin typeface="Courier New" panose="02070309020205020404" pitchFamily="49" charset="0"/>
                   <a:cs typeface="Courier New" panose="02070309020205020404" pitchFamily="49" charset="0"/>
@@ -6171,7 +6177,7 @@
               <a:r>
                 <a:rPr lang="en-US" sz="1000" dirty="0">
                   <a:solidFill>
-                    <a:schemeClr val="tx1"/>
+                    <a:srgbClr val="FF0000"/>
                   </a:solidFill>
                   <a:latin typeface="Courier New" panose="02070309020205020404" pitchFamily="49" charset="0"/>
                   <a:cs typeface="Courier New" panose="02070309020205020404" pitchFamily="49" charset="0"/>
@@ -6181,7 +6187,7 @@
               <a:r>
                 <a:rPr lang="en-US" sz="1000" dirty="0" err="1">
                   <a:solidFill>
-                    <a:schemeClr val="tx1"/>
+                    <a:srgbClr val="FF0000"/>
                   </a:solidFill>
                   <a:latin typeface="Courier New" panose="02070309020205020404" pitchFamily="49" charset="0"/>
                   <a:cs typeface="Courier New" panose="02070309020205020404" pitchFamily="49" charset="0"/>
@@ -6191,7 +6197,7 @@
               <a:r>
                 <a:rPr lang="en-US" sz="1000" dirty="0">
                   <a:solidFill>
-                    <a:schemeClr val="tx1"/>
+                    <a:srgbClr val="FF0000"/>
                   </a:solidFill>
                   <a:latin typeface="Courier New" panose="02070309020205020404" pitchFamily="49" charset="0"/>
                   <a:cs typeface="Courier New" panose="02070309020205020404" pitchFamily="49" charset="0"/>
@@ -6222,9 +6228,9 @@
               <a:avLst/>
             </a:prstGeom>
             <a:noFill/>
-            <a:ln w="12700">
+            <a:ln w="38100">
               <a:solidFill>
-                <a:schemeClr val="tx1"/>
+                <a:srgbClr val="FF0000"/>
               </a:solidFill>
               <a:prstDash val="solid"/>
             </a:ln>
@@ -6253,7 +6259,7 @@
               <a:r>
                 <a:rPr lang="en-US" sz="1400" b="1" dirty="0" err="1">
                   <a:solidFill>
-                    <a:schemeClr val="tx1"/>
+                    <a:srgbClr val="FF0000"/>
                   </a:solidFill>
                   <a:latin typeface="Courier New" panose="02070309020205020404" pitchFamily="49" charset="0"/>
                   <a:cs typeface="Courier New" panose="02070309020205020404" pitchFamily="49" charset="0"/>
@@ -6262,7 +6268,7 @@
               </a:r>
               <a:endParaRPr lang="en-US" sz="1400" b="1" dirty="0">
                 <a:solidFill>
-                  <a:schemeClr val="tx1"/>
+                  <a:srgbClr val="FF0000"/>
                 </a:solidFill>
                 <a:latin typeface="Courier New" panose="02070309020205020404" pitchFamily="49" charset="0"/>
                 <a:cs typeface="Courier New" panose="02070309020205020404" pitchFamily="49" charset="0"/>
@@ -6324,6 +6330,139 @@
     <p:extLst>
       <p:ext uri="{BB962C8B-B14F-4D97-AF65-F5344CB8AC3E}">
         <p14:creationId xmlns:p14="http://schemas.microsoft.com/office/powerpoint/2010/main" val="4033701504"/>
+      </p:ext>
+    </p:extLst>
+  </p:cSld>
+  <p:clrMapOvr>
+    <a:masterClrMapping/>
+  </p:clrMapOvr>
+</p:sld>
+</file>
+
+<file path=ppt/slides/slide2.xml><?xml version="1.0" encoding="utf-8"?>
+<p:sld xmlns:a="http://schemas.openxmlformats.org/drawingml/2006/main" xmlns:r="http://schemas.openxmlformats.org/officeDocument/2006/relationships" xmlns:p="http://schemas.openxmlformats.org/presentationml/2006/main">
+  <p:cSld>
+    <p:spTree>
+      <p:nvGrpSpPr>
+        <p:cNvPr id="1" name=""/>
+        <p:cNvGrpSpPr/>
+        <p:nvPr/>
+      </p:nvGrpSpPr>
+      <p:grpSpPr>
+        <a:xfrm>
+          <a:off x="0" y="0"/>
+          <a:ext cx="0" cy="0"/>
+          <a:chOff x="0" y="0"/>
+          <a:chExt cx="0" cy="0"/>
+        </a:xfrm>
+      </p:grpSpPr>
+      <p:sp>
+        <p:nvSpPr>
+          <p:cNvPr id="2" name="TextBox 1">
+            <a:extLst>
+              <a:ext uri="{FF2B5EF4-FFF2-40B4-BE49-F238E27FC236}">
+                <a16:creationId xmlns:a16="http://schemas.microsoft.com/office/drawing/2014/main" id="{E71FF7CC-935A-0413-7666-7892C7586587}"/>
+              </a:ext>
+            </a:extLst>
+          </p:cNvPr>
+          <p:cNvSpPr txBox="1"/>
+          <p:nvPr/>
+        </p:nvSpPr>
+        <p:spPr>
+          <a:xfrm>
+            <a:off x="257452" y="2415559"/>
+            <a:ext cx="11709647" cy="2031325"/>
+          </a:xfrm>
+          <a:prstGeom prst="rect">
+            <a:avLst/>
+          </a:prstGeom>
+          <a:noFill/>
+        </p:spPr>
+        <p:txBody>
+          <a:bodyPr wrap="square" rtlCol="0" anchor="ctr">
+            <a:spAutoFit/>
+          </a:bodyPr>
+          <a:lstStyle/>
+          <a:p>
+            <a:pPr marL="285750" indent="-285750">
+              <a:buFont typeface="Arial" panose="020B0604020202020204" pitchFamily="34" charset="0"/>
+              <a:buChar char="•"/>
+            </a:pPr>
+            <a:r>
+              <a:rPr lang="en-US" dirty="0"/>
+              <a:t>Add icons to “Resource Files/</a:t>
+            </a:r>
+            <a:r>
+              <a:rPr lang="en-US" dirty="0" err="1"/>
+              <a:t>application.qrc</a:t>
+            </a:r>
+            <a:r>
+              <a:rPr lang="en-US" dirty="0"/>
+              <a:t>”.</a:t>
+            </a:r>
+          </a:p>
+          <a:p>
+            <a:pPr marL="285750" indent="-285750">
+              <a:buFont typeface="Arial" panose="020B0604020202020204" pitchFamily="34" charset="0"/>
+              <a:buChar char="•"/>
+            </a:pPr>
+            <a:r>
+              <a:rPr lang="en-US" dirty="0"/>
+              <a:t>Initialize the initial camera population at “</a:t>
+            </a:r>
+            <a:r>
+              <a:rPr lang="en-US" dirty="0" err="1"/>
+              <a:t>CExtrinsicCalibrationTab</a:t>
+            </a:r>
+            <a:r>
+              <a:rPr lang="en-US" dirty="0"/>
+              <a:t>::Initialize()”. Is it the only place where it’s done?</a:t>
+            </a:r>
+          </a:p>
+          <a:p>
+            <a:pPr marL="285750" indent="-285750">
+              <a:buFont typeface="Arial" panose="020B0604020202020204" pitchFamily="34" charset="0"/>
+              <a:buChar char="•"/>
+            </a:pPr>
+            <a:r>
+              <a:rPr lang="en-US" dirty="0"/>
+              <a:t>Update the layout class scene elements class and its references on “</a:t>
+            </a:r>
+            <a:r>
+              <a:rPr lang="en-US" dirty="0" err="1"/>
+              <a:t>CUfcCalibratorModel</a:t>
+            </a:r>
+            <a:r>
+              <a:rPr lang="en-US" dirty="0"/>
+              <a:t>”. Once updated, all steps that need to be updated will break.</a:t>
+            </a:r>
+          </a:p>
+          <a:p>
+            <a:pPr marL="285750" indent="-285750">
+              <a:buFont typeface="Arial" panose="020B0604020202020204" pitchFamily="34" charset="0"/>
+              <a:buChar char="•"/>
+            </a:pPr>
+            <a:r>
+              <a:rPr lang="en-US" dirty="0"/>
+              <a:t>Update the marker array. Once updated, all steps that need to be updated will break.</a:t>
+            </a:r>
+          </a:p>
+          <a:p>
+            <a:pPr marL="285750" indent="-285750">
+              <a:buFont typeface="Arial" panose="020B0604020202020204" pitchFamily="34" charset="0"/>
+              <a:buChar char="•"/>
+            </a:pPr>
+            <a:r>
+              <a:rPr lang="en-US" dirty="0"/>
+              <a:t>THE DIMENSIONS OF THE INTRINSIC CALIBRATION MATRIX AND THE IMAGES USED DURING THE CALIBRATION SHOULD MATCH!</a:t>
+            </a:r>
+          </a:p>
+        </p:txBody>
+      </p:sp>
+    </p:spTree>
+    <p:extLst>
+      <p:ext uri="{BB962C8B-B14F-4D97-AF65-F5344CB8AC3E}">
+        <p14:creationId xmlns:p14="http://schemas.microsoft.com/office/powerpoint/2010/main" val="3247505239"/>
       </p:ext>
     </p:extLst>
   </p:cSld>

</xml_diff>